<commit_message>
feat(ui): implementar diseño responsivo y actualizar documentación
Se ha mejorado la interfaz de usuario del simulador para que sea responsiva, permitiendo que el diseño se adapte dinámicamente al tamaño de la ventana mediante el uso de layouts flexibles y un mecanismo de debounce para el redimensionamiento. Además, se han actualizado los archivos de documentación del proyecto (informe y presentación) con la información de los integrantes y ajustes en el índice.

Cambios principales:
- Implementación de un layout responsivo en `MainView` que cambia entre una disposición horizontal y vertical según el ancho disponible.
- Ajuste de las dimensiones mínimas y máximas de la ventana en `App` para adaptarse a diferentes resoluciones de pantalla.
- Mejora en `Solid3DView` para permitir el redimensionamiento del contenido 3D.
- Actualización del informe técnico en formato Word y PDF con los nombres de los integrantes y correcciones de estructura.
</commit_message>
<xml_diff>
--- a/entregables/Presentacion_Proyecto_Calculo_II.pptx
+++ b/entregables/Presentacion_Proyecto_Calculo_II.pptx
@@ -4252,8 +4252,8 @@
         </p:nvSpPr>
         <p:spPr>
           <a:xfrm>
-            <a:off x="640080" y="5120640"/>
-            <a:ext cx="10515600" cy="822960"/>
+            <a:off x="640080" y="4572000"/>
+            <a:ext cx="10515600" cy="1828800"/>
           </a:xfrm>
           <a:prstGeom prst="rect">
             <a:avLst/>
@@ -4269,28 +4269,68 @@
               <a:buNone/>
             </a:pPr>
             <a:r>
-              <a:rPr lang="en-US" sz="1600" dirty="0">
+              <a:rPr lang="es-GT" sz="1500" b="1" dirty="0">
                 <a:solidFill>
                   <a:srgbClr val="CBD5E1"/>
                 </a:solidFill>
               </a:rPr>
-              <a:t>Integrantes: [Integrante 1] · [Integrante 2] · [Integrante 3]</a:t>
-            </a:r>
-            <a:endParaRPr lang="en-US" sz="1600" dirty="0"/>
+              <a:t>Integrantes:</a:t>
+            </a:r>
           </a:p>
           <a:p>
             <a:pPr indent="0" marL="0">
               <a:buNone/>
             </a:pPr>
             <a:r>
-              <a:rPr lang="en-US" sz="1600" dirty="0">
+              <a:rPr lang="es-GT" sz="1500" dirty="0">
                 <a:solidFill>
                   <a:srgbClr val="CBD5E1"/>
                 </a:solidFill>
               </a:rPr>
-              <a:t>Docente: Ing. José Alfredo González · Sección [ ] · 25 de octubre de 2026</a:t>
-            </a:r>
-            <a:endParaRPr lang="en-US" sz="1600" dirty="0"/>
+              <a:t>Javier Alejandro Echeverría Figueroa · Carné 3490-25-23600</a:t>
+            </a:r>
+          </a:p>
+          <a:p>
+            <a:pPr indent="0" marL="0">
+              <a:buNone/>
+            </a:pPr>
+            <a:r>
+              <a:rPr lang="es-GT" sz="1500" dirty="0">
+                <a:solidFill>
+                  <a:srgbClr val="CBD5E1"/>
+                </a:solidFill>
+              </a:rPr>
+              <a:t>Fernando Isaac Garcia Baldetti · Carné 3490-25-20014</a:t>
+            </a:r>
+          </a:p>
+          <a:p>
+            <a:pPr indent="0" marL="0">
+              <a:buNone/>
+            </a:pPr>
+            <a:r>
+              <a:rPr lang="es-GT" sz="1500" dirty="0">
+                <a:solidFill>
+                  <a:srgbClr val="CBD5E1"/>
+                </a:solidFill>
+              </a:rPr>
+              <a:t>Edison Vinicio Alvarez Pérez · Carné 3490-25-10745</a:t>
+            </a:r>
+          </a:p>
+          <a:p>
+            <a:pPr indent="0" marL="0">
+              <a:spcBef>
+                <a:spcPts val="900"/>
+              </a:spcBef>
+              <a:buNone/>
+            </a:pPr>
+            <a:r>
+              <a:rPr lang="es-GT" sz="1500" dirty="0">
+                <a:solidFill>
+                  <a:srgbClr val="CBD5E1"/>
+                </a:solidFill>
+              </a:rPr>
+              <a:t>Docente: Ing. José Alfredo González · Sección B · 25 de octubre de 2026</a:t>
+            </a:r>
           </a:p>
         </p:txBody>
       </p:sp>

</xml_diff>